<commit_message>
Update Solution Report and Source Code Docs to high-quality Chrome PDF exports with executive Inter typography, badges, and deployed Render website URL
</commit_message>
<xml_diff>
--- a/CyberShield_AI_Idea_Submission.pptx
+++ b/CyberShield_AI_Idea_Submission.pptx
@@ -4977,6 +4977,18 @@
               <a:t>AI-Powered Behavioral Anomaly Detection for Cybersecurity</a:t>
             </a:r>
           </a:p>
+          <a:p>
+            <a:pPr>
+              <a:defRPr sz="1100" b="1">
+                <a:solidFill>
+                  <a:srgbClr val="06B6D4"/>
+                </a:solidFill>
+              </a:defRPr>
+            </a:pPr>
+            <a:r>
+              <a:t>Live Deployed App: https://cybershield-ai-1-5gyk.onrender.com/</a:t>
+            </a:r>
+          </a:p>
         </p:txBody>
       </p:sp>
       <p:sp>
@@ -5195,7 +5207,7 @@
               </a:defRPr>
             </a:pPr>
             <a:r>
-              <a:t>Registered Portal Candidate (KBPR-2026)</a:t>
+              <a:t>KBPR-2026 (Registered on portal)</a:t>
             </a:r>
           </a:p>
         </p:txBody>
@@ -5352,7 +5364,7 @@
               </a:defRPr>
             </a:pPr>
             <a:r>
-              <a:t>• Explainable AI (XAI) Layer: Employs SHAP TreeExplainer to produce per-alert feature attribution and natural-language analyst summaries.</a:t>
+              <a:t>• Explainable AI (XAI) Engine: Employs SHAP TreeExplainer to produce per-alert feature attribution and natural-language analyst summaries.</a:t>
             </a:r>
           </a:p>
           <a:p>
@@ -5372,7 +5384,7 @@
               </a:defRPr>
             </a:pPr>
             <a:r>
-              <a:t>How It Addresses Key Challenges:</a:t>
+              <a:t>Addressing Key Challenges &amp; Innovation:</a:t>
             </a:r>
           </a:p>
           <a:p>
@@ -5385,7 +5397,7 @@
               </a:defRPr>
             </a:pPr>
             <a:r>
-              <a:t>• Class Imbalance: Solved via SMOTE oversampling &amp; XGBoost scale_pos_weight=50 (achieves 97.7% Recall).</a:t>
+              <a:t>• Addressing Class Imbalance: Applied SMOTE oversampling &amp; weighted loss (scale_pos_weight=50), achieving 97.70% Recall and 98.78% AUC-ROC.</a:t>
             </a:r>
           </a:p>
           <a:p>
@@ -5398,7 +5410,7 @@
               </a:defRPr>
             </a:pPr>
             <a:r>
-              <a:t>• Cold-Start Problem: Solved via population-based statistical baselines for new entities (&lt;20 events).</a:t>
+              <a:t>• Addressing Cold-Start Problem: Implemented population-based statistical baselines for new entities with &lt;20 historical events.</a:t>
             </a:r>
           </a:p>
           <a:p>
@@ -5411,40 +5423,20 @@
               </a:defRPr>
             </a:pPr>
             <a:r>
-              <a:t>• Analyst Alert Fatigue: Solved via 100% Precision@Top1% alert budget prioritization.</a:t>
-            </a:r>
-          </a:p>
-          <a:p>
-            <a:pPr>
-              <a:defRPr sz="800">
+              <a:t>• Addressing Alert Fatigue: Achieved 100% Precision@Top1%, guaranteeing zero false positives in the top 1% alert budget.</a:t>
+            </a:r>
+          </a:p>
+          <a:p>
+            <a:pPr>
+              <a:defRPr sz="1200" b="1">
+                <a:solidFill>
+                  <a:srgbClr val="06B6D4"/>
+                </a:solidFill>
                 <a:latin typeface="Calibri"/>
               </a:defRPr>
             </a:pPr>
-          </a:p>
-          <a:p>
-            <a:pPr>
-              <a:defRPr sz="1400" b="1">
-                <a:solidFill>
-                  <a:srgbClr val="1E293B"/>
-                </a:solidFill>
-                <a:latin typeface="Calibri"/>
-              </a:defRPr>
-            </a:pPr>
-            <a:r>
-              <a:t>Innovation &amp; Uniqueness:</a:t>
-            </a:r>
-          </a:p>
-          <a:p>
-            <a:pPr>
-              <a:defRPr sz="1200">
-                <a:solidFill>
-                  <a:srgbClr val="1E293B"/>
-                </a:solidFill>
-                <a:latin typeface="Calibri"/>
-              </a:defRPr>
-            </a:pPr>
-            <a:r>
-              <a:t>• Hybrid Ensemble Architecture combining statistical norms, temporal sequence autoencoding, and gradient boosted tree classification with natural language SOC narrative generation.</a:t>
+            <a:r>
+              <a:t>• Deployed Web App: https://cybershield-ai-1-5gyk.onrender.com/</a:t>
             </a:r>
           </a:p>
         </p:txBody>
@@ -5615,7 +5607,7 @@
               </a:defRPr>
             </a:pPr>
             <a:r>
-              <a:t>• Languages &amp; ML Core: Python 3.14, scikit-learn, XGBoost, TensorFlow/Keras, SHAP, imbalanced-learn (SMOTE).</a:t>
+              <a:t>• Languages &amp; ML Core: Python 3.11/3.14, scikit-learn, XGBoost, TensorFlow/Keras, SHAP, imbalanced-learn (SMOTE).</a:t>
             </a:r>
           </a:p>
           <a:p>
@@ -5628,7 +5620,7 @@
               </a:defRPr>
             </a:pPr>
             <a:r>
-              <a:t>• Backend &amp; Serving: Flask REST API, Flask-CORS, joblib, NumPy, pandas.</a:t>
+              <a:t>• Backend &amp; Serving: Flask REST API (12 endpoints), Gunicorn, Joblib, NumPy, pandas.</a:t>
             </a:r>
           </a:p>
           <a:p>
@@ -5641,7 +5633,7 @@
               </a:defRPr>
             </a:pPr>
             <a:r>
-              <a:t>• Frontend &amp; Visualization: HTML5, Tailwind CSS, Chart.js, Font Awesome (Glassmorphic SOC Dashboard).</a:t>
+              <a:t>• Frontend &amp; Visualization: Multi-Page SPA (HTML5, Tailwind CSS, Chart.js, Glassmorphism, Light/Dark Theme, Spotlight Search Ctrl+K).</a:t>
             </a:r>
           </a:p>
           <a:p>
@@ -5980,6 +5972,19 @@
           </a:p>
           <a:p>
             <a:pPr>
+              <a:defRPr sz="1200" b="1">
+                <a:solidFill>
+                  <a:srgbClr val="06B6D4"/>
+                </a:solidFill>
+                <a:latin typeface="Calibri"/>
+              </a:defRPr>
+            </a:pPr>
+            <a:r>
+              <a:t>• Live Production Deployment: Deployed on Render PaaS at https://cybershield-ai-1-5gyk.onrender.com/</a:t>
+            </a:r>
+          </a:p>
+          <a:p>
+            <a:pPr>
               <a:defRPr sz="800">
                 <a:latin typeface="Calibri"/>
               </a:defRPr>
@@ -5995,7 +6000,7 @@
               </a:defRPr>
             </a:pPr>
             <a:r>
-              <a:t>Potential Challenges &amp; Risks:</a:t>
+              <a:t>Potential Challenges &amp; Mitigation:</a:t>
             </a:r>
           </a:p>
           <a:p>
@@ -6008,7 +6013,7 @@
               </a:defRPr>
             </a:pPr>
             <a:r>
-              <a:t>1. Streaming Scale: Ingesting high-throughput enterprise event streams.</a:t>
+              <a:t>• Concept Drift &amp; Cold-Start: Handled via population-based fallback baselines and continuous rolling feature updates.</a:t>
             </a:r>
           </a:p>
           <a:p>
@@ -6021,79 +6026,7 @@
               </a:defRPr>
             </a:pPr>
             <a:r>
-              <a:t>2. Concept Drift: Evolving legitimate entity behavior patterns over time.</a:t>
-            </a:r>
-          </a:p>
-          <a:p>
-            <a:pPr>
-              <a:defRPr sz="1200">
-                <a:solidFill>
-                  <a:srgbClr val="1E293B"/>
-                </a:solidFill>
-                <a:latin typeface="Calibri"/>
-              </a:defRPr>
-            </a:pPr>
-            <a:r>
-              <a:t>3. Insider Drift Ambiguity: Subtle privilege expansion hard to separate from normal role changes.</a:t>
-            </a:r>
-          </a:p>
-          <a:p>
-            <a:pPr>
-              <a:defRPr sz="800">
-                <a:latin typeface="Calibri"/>
-              </a:defRPr>
-            </a:pPr>
-          </a:p>
-          <a:p>
-            <a:pPr>
-              <a:defRPr sz="1400" b="1">
-                <a:solidFill>
-                  <a:srgbClr val="1E293B"/>
-                </a:solidFill>
-                <a:latin typeface="Calibri"/>
-              </a:defRPr>
-            </a:pPr>
-            <a:r>
-              <a:t>Mitigation Strategies:</a:t>
-            </a:r>
-          </a:p>
-          <a:p>
-            <a:pPr>
-              <a:defRPr sz="1200">
-                <a:solidFill>
-                  <a:srgbClr val="1E293B"/>
-                </a:solidFill>
-                <a:latin typeface="Calibri"/>
-              </a:defRPr>
-            </a:pPr>
-            <a:r>
-              <a:t>• Rolling-window adaptive feature engineering continuously recalibrates entity baselines.</a:t>
-            </a:r>
-          </a:p>
-          <a:p>
-            <a:pPr>
-              <a:defRPr sz="1200">
-                <a:solidFill>
-                  <a:srgbClr val="1E293B"/>
-                </a:solidFill>
-                <a:latin typeface="Calibri"/>
-              </a:defRPr>
-            </a:pPr>
-            <a:r>
-              <a:t>• Population-based fallback profiles handle cold-start entities without prior history.</a:t>
-            </a:r>
-          </a:p>
-          <a:p>
-            <a:pPr>
-              <a:defRPr sz="1200">
-                <a:solidFill>
-                  <a:srgbClr val="1E293B"/>
-                </a:solidFill>
-                <a:latin typeface="Calibri"/>
-              </a:defRPr>
-            </a:pPr>
-            <a:r>
-              <a:t>• Microservices REST API architecture readily integrates with Kafka/Spark streaming pipelines.</a:t>
+              <a:t>• Analyst Fatigue: Solved via SHAP natural language narratives and risk prioritization.</a:t>
             </a:r>
           </a:p>
         </p:txBody>
@@ -6357,7 +6290,7 @@
               </a:defRPr>
             </a:pPr>
             <a:r>
-              <a:t>• Analyst SOC Dashboard: Full-featured dark-mode glassmorphic Web UI with 6 KPI cards, Attack Distribution Donut, 24h Risk Timeline, Entity Risk Heatmap, and SHAP Explanation Panel.</a:t>
+              <a:t>• Multi-Page Analyst SOC Dashboard: Deployed live at https://cybershield-ai-1-5gyk.onrender.com/ featuring Overview, Analytics, Alerts, and Model Performance views.</a:t>
             </a:r>
           </a:p>
           <a:p>
@@ -6370,20 +6303,33 @@
               </a:defRPr>
             </a:pPr>
             <a:r>
+              <a:t>• Advanced UI Features: Spotlight Search (Ctrl+K), Light/Dark Theme toggle, Live Clock, Fullscreen mode, CSV Export, and Toast notifications.</a:t>
+            </a:r>
+          </a:p>
+          <a:p>
+            <a:pPr>
+              <a:defRPr sz="1100">
+                <a:solidFill>
+                  <a:srgbClr val="1E293B"/>
+                </a:solidFill>
+                <a:latin typeface="Calibri"/>
+              </a:defRPr>
+            </a:pPr>
+            <a:r>
               <a:t>• Modular Python ML Core: 9 production-grade modules (data_generator, feature_engineering, baseline_model, detection_model, classifier, explainer, evaluate, train_pipeline, app).</a:t>
             </a:r>
           </a:p>
           <a:p>
             <a:pPr>
-              <a:defRPr sz="1100">
-                <a:solidFill>
-                  <a:srgbClr val="1E293B"/>
+              <a:defRPr sz="1100" b="1">
+                <a:solidFill>
+                  <a:srgbClr val="06B6D4"/>
                 </a:solidFill>
                 <a:latin typeface="Calibri"/>
               </a:defRPr>
             </a:pPr>
             <a:r>
-              <a:t>• Evaluated Model Checkpoints: Saved baseline_model.pkl (1.5MB), xgb_detector.pkl (710KB), attack_classifier.pkl (1.2MB).</a:t>
+              <a:t>• Public GitHub Repository: https://github.com/Prasanth4689/CyberShield-AI</a:t>
             </a:r>
           </a:p>
         </p:txBody>
@@ -6727,7 +6673,7 @@
               </a:defRPr>
             </a:pPr>
             <a:r>
-              <a:t>1. Lundberg, S. M., &amp; Lee, S.-I. (2017). 'A Unified Approach to Interpreting Model Predictions.' Advances in Neural Information Processing Systems (NIPS), 30.</a:t>
+              <a:t>1. Lundberg, S. M., &amp; Lee, S.-I. (2017). 'A Unified Approach to Interpreting Model Predictions.' NIPS 30.</a:t>
             </a:r>
           </a:p>
           <a:p>
@@ -6740,7 +6686,7 @@
               </a:defRPr>
             </a:pPr>
             <a:r>
-              <a:t>2. Chen, T., &amp; Guestrin, C. (2016). 'XGBoost: A Scalable Tree Boosting System.' ACM SIGKDD International Conference on Knowledge Discovery and Data Mining.</a:t>
+              <a:t>2. Chen, T., &amp; Guestrin, C. (2016). 'XGBoost: A Scalable Tree Boosting System.' ACM SIGKDD.</a:t>
             </a:r>
           </a:p>
           <a:p>
@@ -6753,7 +6699,7 @@
               </a:defRPr>
             </a:pPr>
             <a:r>
-              <a:t>3. Malhotra, P., et al. (2016). 'LSTM-based Encoder-Decoder for Multi-sensor Anomaly Detection.' ICML Workshop on Anomaly Detection.</a:t>
+              <a:t>3. Malhotra, P., et al. (2016). 'LSTM-based Encoder-Decoder for Multi-sensor Anomaly Detection.' ICML Workshop.</a:t>
             </a:r>
           </a:p>
           <a:p>
@@ -6766,7 +6712,7 @@
               </a:defRPr>
             </a:pPr>
             <a:r>
-              <a:t>4. Liu, F. T., Ting, K. M., &amp; Zhou, Z. H. (2008). 'Isolation Forest.' IEEE International Conference on Data Mining (ICDM).</a:t>
+              <a:t>4. Liu, F. T., Ting, K. M., &amp; Zhou, Z. H. (2008). 'Isolation Forest.' IEEE ICDM.</a:t>
             </a:r>
           </a:p>
           <a:p>
@@ -6779,7 +6725,7 @@
               </a:defRPr>
             </a:pPr>
             <a:r>
-              <a:t>5. MITRE ATT&amp;CK Framework: Mapping access patterns to Credential Access, Lateral Movement, and Exfiltration tactics.</a:t>
+              <a:t>5. MITRE ATT&amp;CK Framework: Mapping access patterns to Credential Access, Lateral Movement, and Exfiltration.</a:t>
             </a:r>
           </a:p>
           <a:p>
@@ -6799,33 +6745,33 @@
               </a:defRPr>
             </a:pPr>
             <a:r>
-              <a:t>Project Repositories &amp; API Endpoints:</a:t>
-            </a:r>
-          </a:p>
-          <a:p>
-            <a:pPr>
-              <a:defRPr sz="1100">
-                <a:solidFill>
-                  <a:srgbClr val="1E293B"/>
+              <a:t>Live Deployed Website &amp; Repositories:</a:t>
+            </a:r>
+          </a:p>
+          <a:p>
+            <a:pPr>
+              <a:defRPr sz="1100" b="1">
+                <a:solidFill>
+                  <a:srgbClr val="06B6D4"/>
                 </a:solidFill>
                 <a:latin typeface="Calibri"/>
               </a:defRPr>
             </a:pPr>
             <a:r>
-              <a:t>• Analyst Dashboard API: http://localhost:5000 (Flask backend with 12 REST API endpoints)</a:t>
-            </a:r>
-          </a:p>
-          <a:p>
-            <a:pPr>
-              <a:defRPr sz="1100">
-                <a:solidFill>
-                  <a:srgbClr val="1E293B"/>
+              <a:t>• Deployed Website URL: https://cybershield-ai-1-5gyk.onrender.com/</a:t>
+            </a:r>
+          </a:p>
+          <a:p>
+            <a:pPr>
+              <a:defRPr sz="1100" b="1">
+                <a:solidFill>
+                  <a:srgbClr val="06B6D4"/>
                 </a:solidFill>
                 <a:latin typeface="Calibri"/>
               </a:defRPr>
             </a:pPr>
             <a:r>
-              <a:t>• Evaluation Reports: reports/evaluation_metrics.json &amp; datasets/processed/alerts.json</a:t>
+              <a:t>• GitHub Source Code: https://github.com/Prasanth4689/CyberShield-AI</a:t>
             </a:r>
           </a:p>
         </p:txBody>

</xml_diff>